<commit_message>
Ranking PPTX: nama posisi pakai sebutan lengkap (Teller -> Teller Service)
- src/lib/sip/label-posisi.ts: peta label posisi untuk slide
  Teller -> Teller Service, CS -> Customer Service,
  PB_TELLER -> Priority Banking Teller, PB_CS -> Priority Banking CS
- Hanya untuk TAMPILAN slide; nama jabatan di database dan halaman lain
  (penilaian, pegawai) tidak diubah
- Pencocokan lewat kode jabatan dulu, lalu nama sebagai cadangan; nama yang
  tidak dikenali dikembalikan apa adanya (lebih baik tampil apa adanya
  daripada salah label)
- src/lib/sip/ranking.ts kini mengambil jabatan.kode dan memakai labelPosisi
- label-posisi.test.ts: 7 uji mengunci aturan ini

127 unit test lulus (dari 120) + 20 pemeriksaan ranking lulus.
</commit_message>
<xml_diff>
--- a/ranking-prod.pptx
+++ b/ranking-prod.pptx
@@ -1169,7 +1169,7 @@
               <a:buNone/>
             </a:pPr>
             <a:r>
-              <a:rPr lang="en-US" sz="2400" dirty="0">
+              <a:rPr lang="en-US" sz="1800" dirty="0">
                 <a:solidFill>
                   <a:srgbClr val="FFFFFF"/>
                 </a:solidFill>
@@ -1179,7 +1179,7 @@
               </a:rPr>
               <a:t>Semua posisi</a:t>
             </a:r>
-            <a:endParaRPr lang="en-US" sz="2400" dirty="0"/>
+            <a:endParaRPr lang="en-US" sz="1800" dirty="0"/>
           </a:p>
         </p:txBody>
       </p:sp>
@@ -2477,7 +2477,7 @@
               <a:buNone/>
             </a:pPr>
             <a:r>
-              <a:rPr lang="en-US" sz="2400" dirty="0">
+              <a:rPr lang="en-US" sz="1800" dirty="0">
                 <a:solidFill>
                   <a:srgbClr val="FFFFFF"/>
                 </a:solidFill>
@@ -2487,7 +2487,7 @@
               </a:rPr>
               <a:t>Teller</a:t>
             </a:r>
-            <a:endParaRPr lang="en-US" sz="2400" dirty="0"/>
+            <a:endParaRPr lang="en-US" sz="1800" dirty="0"/>
           </a:p>
         </p:txBody>
       </p:sp>
@@ -2594,7 +2594,7 @@
               <a:buNone/>
             </a:pPr>
             <a:r>
-              <a:rPr lang="en-US" sz="2000" b="1" dirty="0">
+              <a:rPr lang="en-US" sz="1600" b="1" dirty="0">
                 <a:solidFill>
                   <a:srgbClr val="FFFFFF"/>
                 </a:solidFill>
@@ -2604,7 +2604,7 @@
               </a:rPr>
               <a:t>IRWAN ALLO</a:t>
             </a:r>
-            <a:endParaRPr lang="en-US" sz="2000" dirty="0"/>
+            <a:endParaRPr lang="en-US" sz="1600" dirty="0"/>
           </a:p>
         </p:txBody>
       </p:sp>

</xml_diff>